<commit_message>
feat: switch demo to Kimi and improve mobile layout
</commit_message>
<xml_diff>
--- a/assets/QueryForge-Pitch-EN.pptx
+++ b/assets/QueryForge-Pitch-EN.pptx
@@ -3481,7 +3481,7 @@
                 </a:solidFill>
                 <a:latin typeface="Aptos"/>
               </a:rPr>
-              <a:t>Powered by MiMo v2.5 Pro</a:t>
+              <a:t>Powered by Kimi K2.7</a:t>
             </a:r>
           </a:p>
           <a:p>
@@ -10953,7 +10953,7 @@
                 </a:solidFill>
                 <a:latin typeface="Aptos"/>
               </a:rPr>
-              <a:t>Built at ClawHunt Builder Camp 2026 in 72 hours | MiMo v2.5 Pro</a:t>
+              <a:t>Built at ClawHunt Builder Camp 2026 in 72 hours | Kimi K2.7</a:t>
             </a:r>
           </a:p>
         </p:txBody>

</xml_diff>